<commit_message>
chore: repositórios migrados para a organização RGMThech
- links do Squad Console e endereço no deck apontam para RGMThech
- docs/console.md: permissão do Actions para criar PRs

Co-Authored-By: Claude Opus 5.5 <noreply@anthropic.com>
Claude-Session: https://claude.ai/code/session_01UGo7iW7XFpKqDuC9PgcBiL
</commit_message>
<xml_diff>
--- a/docs/apresentacao/squad-agentica-data-analytics.pptx
+++ b/docs/apresentacao/squad-agentica-data-analytics.pptx
@@ -118,42 +118,42 @@
   <p:extLst>
     <p:ext uri="{521415D9-36F7-43E2-AB2F-B90AF26B5E84}">
       <p14:sectionLst xmlns:p14="http://schemas.microsoft.com/office/powerpoint/2010/main">
-        <p14:section name="Abertura" id="{49d38bab-ebfb-f28c-e903-92b18c6d0832}">
+        <p14:section name="Abertura" id="{b348ed42-05e8-8400-8844-b246fdc9bf2d}">
           <p14:sldIdLst>
             <p14:sldId id="256"/>
           </p14:sldIdLst>
         </p14:section>
-        <p14:section name="Conceito" id="{a4b29bee-a18a-fb78-afdb-670ca66731b0}">
+        <p14:section name="Conceito" id="{e584bc69-c526-bd21-32e7-8567f79c1723}">
           <p14:sldIdLst>
             <p14:sldId id="257"/>
             <p14:sldId id="258"/>
           </p14:sldIdLst>
         </p14:section>
-        <p14:section name="Squad" id="{c746ac17-eb1b-1816-8ad4-703cc88e7525}">
+        <p14:section name="Squad" id="{d4622363-3485-314f-d702-528e9960cec1}">
           <p14:sldIdLst>
             <p14:sldId id="259"/>
             <p14:sldId id="260"/>
           </p14:sldIdLst>
         </p14:section>
-        <p14:section name="Fluxo e Harness" id="{189859a8-d28f-44ab-9cc9-927182abf433}">
+        <p14:section name="Fluxo e Harness" id="{6a1ea5b7-3449-00eb-90ca-d92edfb9469f}">
           <p14:sldIdLst>
             <p14:sldId id="261"/>
             <p14:sldId id="262"/>
             <p14:sldId id="263"/>
           </p14:sldIdLst>
         </p14:section>
-        <p14:section name="Exemplo" id="{3abe56fc-d8e5-0a11-5f81-d0cc85bf4d9a}">
+        <p14:section name="Exemplo" id="{e32d248e-6eeb-4219-0a2d-a8f6ac0267fc}">
           <p14:sldIdLst>
             <p14:sldId id="264"/>
           </p14:sldIdLst>
         </p14:section>
-        <p14:section name="Implantação" id="{dcd0cc23-6511-45f1-d073-88d7eba18227}">
+        <p14:section name="Implantação" id="{aa350223-2b32-ec4d-f709-4ee65299a84c}">
           <p14:sldIdLst>
             <p14:sldId id="265"/>
             <p14:sldId id="266"/>
           </p14:sldIdLst>
         </p14:section>
-        <p14:section name="Encerramento" id="{7e807987-a212-436d-b064-fbd00e9e1821}">
+        <p14:section name="Encerramento" id="{f194c3db-28ab-c694-e3b1-f0f955abb9fa}">
           <p14:sldIdLst>
             <p14:sldId id="267"/>
           </p14:sldIdLst>
@@ -4971,7 +4971,7 @@
                 <a:ea typeface="Courier New" pitchFamily="34" charset="-122"/>
                 <a:cs typeface="Courier New" pitchFamily="34" charset="-120"/>
               </a:rPr>
-              <a:t>github.com/mellrodrigo/agentic-data-squad</a:t>
+              <a:t>github.com/RGMThech/agentic-data-squad</a:t>
             </a:r>
             <a:endParaRPr lang="en-US" sz="1200" dirty="0"/>
           </a:p>

</xml_diff>

<commit_message>
feat: execuções pedidas pelo GitHub App do console; marca RGM Tech
- squad-agent recebe 'solicitante' (e-mail de quem pediu no console)
- squad_run.py: quando o ator é o console_bot, valida o solicitante contra
  .squad/members.yaml; em disparo manual vale o login de quem disparou
- check_spec.py: operadores por e-mail, sem diferenciar maiúsculas
- .squad/squad.yaml: campo console_bot; cliente RGM Tech
- deck e docs sem referências a outras empresas

Co-Authored-By: Claude Opus 5.5 <noreply@anthropic.com>
Claude-Session: https://claude.ai/code/session_01UGo7iW7XFpKqDuC9PgcBiL
</commit_message>
<xml_diff>
--- a/docs/apresentacao/squad-agentica-data-analytics.pptx
+++ b/docs/apresentacao/squad-agentica-data-analytics.pptx
@@ -118,42 +118,42 @@
   <p:extLst>
     <p:ext uri="{521415D9-36F7-43E2-AB2F-B90AF26B5E84}">
       <p14:sectionLst xmlns:p14="http://schemas.microsoft.com/office/powerpoint/2010/main">
-        <p14:section name="Abertura" id="{b348ed42-05e8-8400-8844-b246fdc9bf2d}">
+        <p14:section name="Abertura" id="{d2a7764b-7f2a-5a86-41cf-b79a1aad94cc}">
           <p14:sldIdLst>
             <p14:sldId id="256"/>
           </p14:sldIdLst>
         </p14:section>
-        <p14:section name="Conceito" id="{e584bc69-c526-bd21-32e7-8567f79c1723}">
+        <p14:section name="Conceito" id="{eb60ab05-0234-1494-0f84-3f67018c8bf8}">
           <p14:sldIdLst>
             <p14:sldId id="257"/>
             <p14:sldId id="258"/>
           </p14:sldIdLst>
         </p14:section>
-        <p14:section name="Squad" id="{d4622363-3485-314f-d702-528e9960cec1}">
+        <p14:section name="Squad" id="{abaa1864-c887-28da-089b-a3a09f4509eb}">
           <p14:sldIdLst>
             <p14:sldId id="259"/>
             <p14:sldId id="260"/>
           </p14:sldIdLst>
         </p14:section>
-        <p14:section name="Fluxo e Harness" id="{6a1ea5b7-3449-00eb-90ca-d92edfb9469f}">
+        <p14:section name="Fluxo e Harness" id="{f588b2bd-1110-7a34-e17d-d913db3d6454}">
           <p14:sldIdLst>
             <p14:sldId id="261"/>
             <p14:sldId id="262"/>
             <p14:sldId id="263"/>
           </p14:sldIdLst>
         </p14:section>
-        <p14:section name="Exemplo" id="{e32d248e-6eeb-4219-0a2d-a8f6ac0267fc}">
+        <p14:section name="Exemplo" id="{6f03602d-fa58-2d52-1ed7-3313c1ed9d8e}">
           <p14:sldIdLst>
             <p14:sldId id="264"/>
           </p14:sldIdLst>
         </p14:section>
-        <p14:section name="Implantação" id="{aa350223-2b32-ec4d-f709-4ee65299a84c}">
+        <p14:section name="Implantação" id="{16746f8a-461b-0b3a-29a9-e15fdef44d99}">
           <p14:sldIdLst>
             <p14:sldId id="265"/>
             <p14:sldId id="266"/>
           </p14:sldIdLst>
         </p14:section>
-        <p14:section name="Encerramento" id="{f194c3db-28ab-c694-e3b1-f0f955abb9fa}">
+        <p14:section name="Encerramento" id="{7899b2ee-21d8-016b-0fbd-8277b405e7be}">
           <p14:sldIdLst>
             <p14:sldId id="267"/>
           </p14:sldIdLst>
@@ -650,7 +650,7 @@
           <a:p>
             <a:r>
               <a:rPr lang="en-US" dirty="0"/>
-              <a:t>Sugestão de piloto: uma frente com convenções já decididas, por exemplo o Data Lake da Serasa, onde catálogos por domínio e naming padronizado viram regras de harness quase prontas.</a:t>
+              <a:t>Sugestão de piloto: uma frente com convenções já decididas, como catálogos por domínio e naming padronizado, que viram regras de harness quase prontas.</a:t>
             </a:r>
             <a:endParaRPr lang="en-US" dirty="0"/>
           </a:p>
@@ -1656,7 +1656,7 @@
                   <a:schemeClr val="bg1"/>
                 </a:solidFill>
               </a:rPr>
-              <a:t>NTT DATA</a:t>
+              <a:t>RGM TECH</a:t>
             </a:r>
             <a:endParaRPr lang="en-US" sz="1100" dirty="0"/>
           </a:p>
@@ -1802,7 +1802,7 @@
                   <a:schemeClr val="accent1"/>
                 </a:solidFill>
               </a:rPr>
-              <a:t>NTT DATA  |  Data &amp; AI</a:t>
+              <a:t>RGM TECH  |  Squad Agêntica</a:t>
             </a:r>
             <a:endParaRPr lang="en-US" sz="1000" dirty="0"/>
           </a:p>
@@ -1954,7 +1954,7 @@
                   <a:schemeClr val="bg1"/>
                 </a:solidFill>
               </a:rPr>
-              <a:t>NTT DATA</a:t>
+              <a:t>RGM TECH</a:t>
             </a:r>
             <a:endParaRPr lang="en-US" sz="1100" dirty="0"/>
           </a:p>
@@ -2764,7 +2764,7 @@
                   <a:schemeClr val="bg1"/>
                 </a:solidFill>
               </a:rPr>
-              <a:t>Rodrigo  ·  Project Leader, Data &amp; AI  ·  Outubro 2026</a:t>
+              <a:t>Rodrigo  ·  RGM Tech  ·  Outubro 2026</a:t>
             </a:r>
             <a:endParaRPr lang="en-US" sz="1400" dirty="0"/>
           </a:p>
@@ -13322,9 +13322,9 @@
 </file>
 
 <file path=ppt/theme/theme1.xml><?xml version="1.0" encoding="utf-8"?>
-<a:theme xmlns:a="http://schemas.openxmlformats.org/drawingml/2006/main" name="NTT DATA Squad">
+<a:theme xmlns:a="http://schemas.openxmlformats.org/drawingml/2006/main" name="RGM Tech Squad">
   <a:themeElements>
-    <a:clrScheme name="NTT DATA Squad">
+    <a:clrScheme name="RGM Tech Squad">
       <a:dk1>
         <a:srgbClr val="070F26"/>
       </a:dk1>
@@ -13362,7 +13362,7 @@
         <a:srgbClr val="5A6B85"/>
       </a:folHlink>
     </a:clrScheme>
-    <a:fontScheme name="NTT DATA Squad">
+    <a:fontScheme name="RGM Tech Squad">
       <a:majorFont>
         <a:latin typeface="Arial"/>
         <a:ea typeface=""/>

</xml_diff>